<commit_message>
Actually polishing the languages
</commit_message>
<xml_diff>
--- a/writeup2/poster-summer-1.1/summer_showcase.pptx
+++ b/writeup2/poster-summer-1.1/summer_showcase.pptx
@@ -3523,7 +3523,7 @@
               </a:defRPr>
             </a:pPr>
             <a:r>
-              <a:t>Soil moisture is the amount of water held in soil. Daily estimates help</a:t>
+              <a:t>Soil moisture regulates agricultural productivity and drought resilience,</a:t>
             </a:r>
           </a:p>
           <a:p>
@@ -3545,7 +3545,7 @@
               </a:defRPr>
             </a:pPr>
             <a:r>
-              <a:t>with irrigation planning and drought monitoring. They show how</a:t>
+              <a:t>making daily estimates vital for water management. High-resolution</a:t>
             </a:r>
           </a:p>
           <a:p>
@@ -3567,7 +3567,7 @@
               </a:defRPr>
             </a:pPr>
             <a:r>
-              <a:t>moisture changes after rain and during dry periods, including places</a:t>
+              <a:t>modeling tracks moisture recharge and drydown dynamics, particularly</a:t>
             </a:r>
           </a:p>
           <a:p>
@@ -3589,7 +3589,7 @@
               </a:defRPr>
             </a:pPr>
             <a:r>
-              <a:t>with few direct measurements.</a:t>
+              <a:t>across regions lacking direct measurement infrastructure.</a:t>
             </a:r>
           </a:p>
         </p:txBody>
@@ -3634,7 +3634,7 @@
               </a:defRPr>
             </a:pPr>
             <a:r>
-              <a:t>Ground sensors measure moisture at individual sites. Satellite</a:t>
+              <a:t>While in-situ ground sensors offer accurate readings, they exist only at</a:t>
             </a:r>
           </a:p>
           <a:p>
@@ -3656,7 +3656,7 @@
               </a:defRPr>
             </a:pPr>
             <a:r>
-              <a:t>observations cover larger areas but are intermittent, with some</a:t>
+              <a:t>limited monitoring sites. Satellite observations span broader regions</a:t>
             </a:r>
           </a:p>
           <a:p>
@@ -3678,7 +3678,7 @@
               </a:defRPr>
             </a:pPr>
             <a:r>
-              <a:t>retrievals missing. We combine satellite, weather, and site data for</a:t>
+              <a:t>but remain intermittent with frequent data gaps. To generate daily</a:t>
             </a:r>
           </a:p>
           <a:p>
@@ -3700,7 +3700,7 @@
               </a:defRPr>
             </a:pPr>
             <a:r>
-              <a:t>daily estimates. Earlier work produced the pipeline and a global</a:t>
+              <a:t>estimates, multi-source modeling combines satellite, weather, and site</a:t>
             </a:r>
           </a:p>
           <a:p>
@@ -3722,7 +3722,7 @@
               </a:defRPr>
             </a:pPr>
             <a:r>
-              <a:t>XGBoost model.</a:t>
+              <a:t>data, extending an established pipeline and global XGBoost baseline.</a:t>
             </a:r>
           </a:p>
         </p:txBody>
@@ -3926,7 +3926,7 @@
               </a:defRPr>
             </a:pPr>
             <a:r>
-              <a:t>Our comparison uses the same evaluation conditions for both models.</a:t>
+              <a:t>Both models are compared under identical benchmarks. For known</a:t>
             </a:r>
           </a:p>
           <a:p>
@@ -3948,7 +3948,7 @@
               </a:defRPr>
             </a:pPr>
             <a:r>
-              <a:t>For known stations, we fix a single specialist; tests at new sites</a:t>
+              <a:t>stations, we assign a fixed specialist; tests at new sites evaluate</a:t>
             </a:r>
           </a:p>
           <a:p>
@@ -3970,7 +3970,7 @@
               </a:defRPr>
             </a:pPr>
             <a:r>
-              <a:t>examine how missing satellite inputs affect assignment.</a:t>
+              <a:t>dynamic routing under missing satellite inputs.</a:t>
             </a:r>
           </a:p>
         </p:txBody>
@@ -4145,7 +4145,7 @@
         <p:spPr>
           <a:xfrm>
             <a:off x="7406640" y="11609070"/>
-            <a:ext cx="3337560" cy="3296919"/>
+            <a:ext cx="3337560" cy="2997200"/>
           </a:xfrm>
           <a:prstGeom prst="rect">
             <a:avLst/>
@@ -4176,7 +4176,7 @@
               </a:defRPr>
             </a:pPr>
             <a:r>
-              <a:t>Our stations span the</a:t>
+              <a:t>Stations span coastal</a:t>
             </a:r>
           </a:p>
           <a:p>
@@ -4198,7 +4198,7 @@
               </a:defRPr>
             </a:pPr>
             <a:r>
-              <a:t>coast, Cascade</a:t>
+              <a:t>areas, the Cascade</a:t>
             </a:r>
           </a:p>
           <a:p>
@@ -4220,7 +4220,7 @@
               </a:defRPr>
             </a:pPr>
             <a:r>
-              <a:t>mountains, and drier</a:t>
+              <a:t>mountains, and arid</a:t>
             </a:r>
           </a:p>
           <a:p>
@@ -4242,7 +4242,7 @@
               </a:defRPr>
             </a:pPr>
             <a:r>
-              <a:t>eastern Washington.</a:t>
+              <a:t>eastern Washington,</a:t>
             </a:r>
           </a:p>
           <a:p>
@@ -4264,7 +4264,7 @@
               </a:defRPr>
             </a:pPr>
             <a:r>
-              <a:t>They let us study how soil</a:t>
+              <a:t>capturing contrasting</a:t>
             </a:r>
           </a:p>
           <a:p>
@@ -4286,7 +4286,7 @@
               </a:defRPr>
             </a:pPr>
             <a:r>
-              <a:t>moisture relates to inputs</a:t>
+              <a:t>hydroclimatic regimes.</a:t>
             </a:r>
           </a:p>
           <a:p>
@@ -4308,7 +4308,7 @@
               </a:defRPr>
             </a:pPr>
             <a:r>
-              <a:t>under different</a:t>
+              <a:t>Leave-one-station-out</a:t>
             </a:r>
           </a:p>
           <a:p>
@@ -4330,7 +4330,7 @@
               </a:defRPr>
             </a:pPr>
             <a:r>
-              <a:t>conditions. Station</a:t>
+              <a:t>evaluations test model</a:t>
             </a:r>
           </a:p>
           <a:p>
@@ -4352,7 +4352,7 @@
               </a:defRPr>
             </a:pPr>
             <a:r>
-              <a:t>holdouts test whether the</a:t>
+              <a:t>generalization across</a:t>
             </a:r>
           </a:p>
           <a:p>
@@ -4374,29 +4374,7 @@
               </a:defRPr>
             </a:pPr>
             <a:r>
-              <a:t>models can estimate</a:t>
-            </a:r>
-          </a:p>
-          <a:p>
-            <a:pPr algn="l">
-              <a:lnSpc>
-                <a:spcPts val="2360"/>
-              </a:lnSpc>
-              <a:spcBef>
-                <a:spcPts val="0"/>
-              </a:spcBef>
-              <a:spcAft>
-                <a:spcPts val="0"/>
-              </a:spcAft>
-              <a:defRPr sz="2000" b="0">
-                <a:solidFill>
-                  <a:srgbClr val="536875"/>
-                </a:solidFill>
-                <a:latin typeface="DejaVu Sans"/>
-              </a:defRPr>
-            </a:pPr>
-            <a:r>
-              <a:t>moisture at a new site.</a:t>
+              <a:t>unseen microclimates.</a:t>
             </a:r>
           </a:p>
         </p:txBody>
@@ -4441,7 +4419,7 @@
               </a:defRPr>
             </a:pPr>
             <a:r>
-              <a:t>Figure 1. The seven training stations and their fitted groups. Colors identify</a:t>
+              <a:t>Figure 1. Seven Washington training stations and their assigned clusters.</a:t>
             </a:r>
           </a:p>
           <a:p>
@@ -4463,7 +4441,7 @@
               </a:defRPr>
             </a:pPr>
             <a:r>
-              <a:t>station assignments, with no geographic boundaries implied.</a:t>
+              <a:t>Colors designate cluster regimes, with no geographic boundaries implied.</a:t>
             </a:r>
           </a:p>
         </p:txBody>
@@ -4477,7 +4455,7 @@
         <p:spPr>
           <a:xfrm>
             <a:off x="685800" y="15811246"/>
-            <a:ext cx="10058400" cy="2307844"/>
+            <a:ext cx="10058400" cy="1978151"/>
           </a:xfrm>
           <a:prstGeom prst="rect">
             <a:avLst/>
@@ -4508,7 +4486,7 @@
               </a:defRPr>
             </a:pPr>
             <a:r>
-              <a:t>NOAA USCRN and SNOTEL stations provide measured soil moisture.</a:t>
+              <a:t>In-situ ground truth for soil moisture comes from NOAA USCRN and</a:t>
             </a:r>
           </a:p>
           <a:p>
@@ -4530,7 +4508,7 @@
               </a:defRPr>
             </a:pPr>
             <a:r>
-              <a:t>Satellite inputs include SMAP soil moisture, Sentinel-1 radar</a:t>
+              <a:t>SNOTEL stations. Satellite inputs comprise SMAP soil moisture,</a:t>
             </a:r>
           </a:p>
           <a:p>
@@ -4552,7 +4530,7 @@
               </a:defRPr>
             </a:pPr>
             <a:r>
-              <a:t>backscatter from the land surface, and Sentinel-2 surface reflectance</a:t>
+              <a:t>Sentinel-1 radar backscatter from the land surface, and Sentinel-2</a:t>
             </a:r>
           </a:p>
           <a:p>
@@ -4574,7 +4552,7 @@
               </a:defRPr>
             </a:pPr>
             <a:r>
-              <a:t>and indices of vegetation greenness and canopy water content. We</a:t>
+              <a:t>surface reflectance and indices of vegetation greenness and canopy</a:t>
             </a:r>
           </a:p>
           <a:p>
@@ -4596,7 +4574,7 @@
               </a:defRPr>
             </a:pPr>
             <a:r>
-              <a:t>also use MODIS land-surface temperature and vegetation indices,</a:t>
+              <a:t>water content. We use MODIS land-surface temperature, ERA5-Land</a:t>
             </a:r>
           </a:p>
           <a:p>
@@ -4618,29 +4596,7 @@
               </a:defRPr>
             </a:pPr>
             <a:r>
-              <a:t>ERA5-Land weather, and terrain, climate, land-cover, and soil</a:t>
-            </a:r>
-          </a:p>
-          <a:p>
-            <a:pPr algn="l">
-              <a:lnSpc>
-                <a:spcPts val="2595"/>
-              </a:lnSpc>
-              <a:spcBef>
-                <a:spcPts val="0"/>
-              </a:spcBef>
-              <a:spcAft>
-                <a:spcPts val="0"/>
-              </a:spcAft>
-              <a:defRPr sz="2200" b="0">
-                <a:solidFill>
-                  <a:srgbClr val="202B35"/>
-                </a:solidFill>
-                <a:latin typeface="DejaVu Sans"/>
-              </a:defRPr>
-            </a:pPr>
-            <a:r>
-              <a:t>descriptors.</a:t>
+              <a:t>weather, and terrain, soil, and climate descriptors.</a:t>
             </a:r>
           </a:p>
         </p:txBody>
@@ -4653,7 +4609,7 @@
         </p:nvSpPr>
         <p:spPr>
           <a:xfrm>
-            <a:off x="685800" y="18228818"/>
+            <a:off x="685800" y="17899126"/>
             <a:ext cx="10058400" cy="989075"/>
           </a:xfrm>
           <a:prstGeom prst="rect">
@@ -4685,7 +4641,7 @@
               </a:defRPr>
             </a:pPr>
             <a:r>
-              <a:t>The pipeline puts observations on a daily grid, fills gaps, smooths the</a:t>
+              <a:t>The data pipeline aligns observations onto a daily grid, imputes</a:t>
             </a:r>
           </a:p>
           <a:p>
@@ -4707,7 +4663,7 @@
               </a:defRPr>
             </a:pPr>
             <a:r>
-              <a:t>time series, and calculates features describing recent satellite readings</a:t>
+              <a:t>missing values, smooths temporal sequences, and extracts rolling lag</a:t>
             </a:r>
           </a:p>
           <a:p>
@@ -4729,7 +4685,7 @@
               </a:defRPr>
             </a:pPr>
             <a:r>
-              <a:t>and weather.</a:t>
+              <a:t>features capturing recent weather and satellite signals.</a:t>
             </a:r>
           </a:p>
         </p:txBody>
@@ -4742,7 +4698,7 @@
         </p:nvSpPr>
         <p:spPr>
           <a:xfrm>
-            <a:off x="731520" y="19327622"/>
+            <a:off x="731520" y="18997930"/>
             <a:ext cx="4663440" cy="932688"/>
           </a:xfrm>
           <a:prstGeom prst="roundRect">
@@ -4787,7 +4743,7 @@
         </p:nvSpPr>
         <p:spPr>
           <a:xfrm>
-            <a:off x="868680" y="19446494"/>
+            <a:off x="868680" y="19116802"/>
             <a:ext cx="4389120" cy="667512"/>
           </a:xfrm>
           <a:prstGeom prst="rect">
@@ -4854,7 +4810,7 @@
         </p:nvSpPr>
         <p:spPr>
           <a:xfrm>
-            <a:off x="6035040" y="19327622"/>
+            <a:off x="6035040" y="18997930"/>
             <a:ext cx="4663440" cy="932688"/>
           </a:xfrm>
           <a:prstGeom prst="roundRect">
@@ -4899,7 +4855,7 @@
         </p:nvSpPr>
         <p:spPr>
           <a:xfrm>
-            <a:off x="6172200" y="19446494"/>
+            <a:off x="6172200" y="19116802"/>
             <a:ext cx="4389120" cy="667512"/>
           </a:xfrm>
           <a:prstGeom prst="rect">
@@ -4966,7 +4922,7 @@
         </p:nvCxnSpPr>
         <p:spPr>
           <a:xfrm>
-            <a:off x="5522976" y="19793966"/>
+            <a:off x="5522976" y="19464274"/>
             <a:ext cx="411480" cy="0"/>
           </a:xfrm>
           <a:prstGeom prst="line">
@@ -5002,7 +4958,7 @@
         </p:nvSpPr>
         <p:spPr>
           <a:xfrm>
-            <a:off x="685800" y="20424902"/>
+            <a:off x="685800" y="20095210"/>
             <a:ext cx="10058400" cy="989075"/>
           </a:xfrm>
           <a:prstGeom prst="rect">
@@ -5034,7 +4990,7 @@
               </a:defRPr>
             </a:pPr>
             <a:r>
-              <a:t>Development uses 2017 to 2020 for training and 2021 to 2022 for</a:t>
+              <a:t>We train the models with data from 2017 to 2022. We evaluate</a:t>
             </a:r>
           </a:p>
           <a:p>
@@ -5056,7 +5012,7 @@
               </a:defRPr>
             </a:pPr>
             <a:r>
-              <a:t>validation. The final fit combines both periods. We test later years and</a:t>
+              <a:t>temporal generalization on later years (2023 to 2025) and test new</a:t>
             </a:r>
           </a:p>
           <a:p>
@@ -5078,7 +5034,7 @@
               </a:defRPr>
             </a:pPr>
             <a:r>
-              <a:t>refit without each station in turn to evaluate new Washington locations.</a:t>
+              <a:t>Washington sites using leave-one-station-out cross-validation.</a:t>
             </a:r>
           </a:p>
         </p:txBody>
@@ -5215,7 +5171,7 @@
               </a:defRPr>
             </a:pPr>
             <a:r>
-              <a:t>A global model learns one input-to-soil-moisture relationship from all</a:t>
+              <a:t>A single global model enforces one input-to-moisture mapping across</a:t>
             </a:r>
           </a:p>
           <a:p>
@@ -5237,7 +5193,7 @@
               </a:defRPr>
             </a:pPr>
             <a:r>
-              <a:t>stations. We divide observations into two groups and fit an XGBoost</a:t>
+              <a:t>all stations. We divide observations into two environmental regimes</a:t>
             </a:r>
           </a:p>
           <a:p>
@@ -5259,7 +5215,7 @@
               </a:defRPr>
             </a:pPr>
             <a:r>
-              <a:t>model to each. Each specialist predicts daily volumetric soil moisture</a:t>
+              <a:t>and fit a dedicated XGBoost specialist to each. Each specialist predicts</a:t>
             </a:r>
           </a:p>
           <a:p>
@@ -5281,7 +5237,7 @@
               </a:defRPr>
             </a:pPr>
             <a:r>
-              <a:t>at 5 cm depth (m³/m³).</a:t>
+              <a:t>daily volumetric soil moisture at 5 cm depth (m³/m³).</a:t>
             </a:r>
           </a:p>
         </p:txBody>
@@ -6916,7 +6872,7 @@
               </a:defRPr>
             </a:pPr>
             <a:r>
-              <a:t>Figure 2. Each observation uses one specialist. x denotes the inputs, s the</a:t>
+              <a:t>Figure 2. Two-regime routing: each observation is assigned to a specialist fᵣ,</a:t>
             </a:r>
           </a:p>
           <a:p>
@@ -6938,7 +6894,7 @@
               </a:defRPr>
             </a:pPr>
             <a:r>
-              <a:t>station, g the assignment rule, and fᵣ the selected model.</a:t>
+              <a:t>where x denotes input features, s the station, and g the routing function.</a:t>
             </a:r>
           </a:p>
         </p:txBody>
@@ -6983,7 +6939,7 @@
               </a:defRPr>
             </a:pPr>
             <a:r>
-              <a:t>1. We fill missing router inputs with their fitting-data means and</a:t>
+              <a:t>1. Router inputs are imputed using training-set means and</a:t>
             </a:r>
           </a:p>
           <a:p>
@@ -7005,7 +6961,7 @@
               </a:defRPr>
             </a:pPr>
             <a:r>
-              <a:t>standardize features to comparable scales. K-means finds two cluster</a:t>
+              <a:t>standardized to comparable scales. K-means clustering identifies two</a:t>
             </a:r>
           </a:p>
           <a:p>
@@ -7027,7 +6983,7 @@
               </a:defRPr>
             </a:pPr>
             <a:r>
-              <a:t>centers; a new observation goes to the nearest center. The router uses</a:t>
+              <a:t>centroids, assigning unseen samples to the nearest centroid using</a:t>
             </a:r>
           </a:p>
           <a:p>
@@ -7049,7 +7005,7 @@
               </a:defRPr>
             </a:pPr>
             <a:r>
-              <a:t>inputs alone, without measured target labels.</a:t>
+              <a:t>feature inputs alone without target labels.</a:t>
             </a:r>
           </a:p>
         </p:txBody>
@@ -7094,7 +7050,7 @@
               </a:defRPr>
             </a:pPr>
             <a:r>
-              <a:t>2. For a station included in fitting, its most common group selects one</a:t>
+              <a:t>2. For known stations, each adopts its majority cluster specialist for</a:t>
             </a:r>
           </a:p>
           <a:p>
@@ -7116,7 +7072,7 @@
               </a:defRPr>
             </a:pPr>
             <a:r>
-              <a:t>specialist for all its observations. New stations receive an assignment</a:t>
+              <a:t>temporal consistency. New stations are routed dynamically each day,</a:t>
             </a:r>
           </a:p>
           <a:p>
@@ -7138,7 +7094,7 @@
               </a:defRPr>
             </a:pPr>
             <a:r>
-              <a:t>each day. Missing routing inputs can trigger the precipitation fallback.</a:t>
+              <a:t>falling back to rainfall rules if satellite features are missing.</a:t>
             </a:r>
           </a:p>
         </p:txBody>
@@ -7205,7 +7161,7 @@
               </a:defRPr>
             </a:pPr>
             <a:r>
-              <a:t>evaluation observations, and random seeds. Each specialist trains on</a:t>
+              <a:t>evaluation splits, and random seeds. Each specialist trains solely on its</a:t>
             </a:r>
           </a:p>
           <a:p>
@@ -7227,7 +7183,7 @@
               </a:defRPr>
             </a:pPr>
             <a:r>
-              <a:t>its assigned group. Seeds control training randomness; repeated fits</a:t>
+              <a:t>assigned regime. Testing 30 repeated seeds quantifies training</a:t>
             </a:r>
           </a:p>
           <a:p>
@@ -7249,7 +7205,7 @@
               </a:defRPr>
             </a:pPr>
             <a:r>
-              <a:t>measure training variation, leaving uncertainty across new sites and</a:t>
+              <a:t>stability, while station-holdout splits evaluate spatial generalization</a:t>
             </a:r>
           </a:p>
           <a:p>
@@ -7271,7 +7227,7 @@
               </a:defRPr>
             </a:pPr>
             <a:r>
-              <a:t>seasons unmeasured.</a:t>
+              <a:t>uncertainty.</a:t>
             </a:r>
           </a:p>
         </p:txBody>
@@ -8080,7 +8036,7 @@
               </a:defRPr>
             </a:pPr>
             <a:r>
-              <a:t>The groups differ mainly in rainfall and SMAP soil moisture. The wetter</a:t>
+              <a:t>The regimes separate primarily along gradients of rainfall and SMAP</a:t>
             </a:r>
           </a:p>
           <a:p>
@@ -8102,7 +8058,7 @@
               </a:defRPr>
             </a:pPr>
             <a:r>
-              <a:t>group includes lowland and mountain stations, so elevation alone does</a:t>
+              <a:t>soil moisture. Because the wetter group includes lowland and</a:t>
             </a:r>
           </a:p>
           <a:p>
@@ -8124,7 +8080,7 @@
               </a:defRPr>
             </a:pPr>
             <a:r>
-              <a:t>not distinguish them. Values above are input-data medians. Two</a:t>
+              <a:t>mountain stations, elevation alone does not distinguish them.</a:t>
             </a:r>
           </a:p>
           <a:p>
@@ -8146,7 +8102,7 @@
               </a:defRPr>
             </a:pPr>
             <a:r>
-              <a:t>groups worked for these stations; other deployments should choose</a:t>
+              <a:t>Displayed values are input medians; other deployments should select</a:t>
             </a:r>
           </a:p>
           <a:p>
@@ -8168,7 +8124,7 @@
               </a:defRPr>
             </a:pPr>
             <a:r>
-              <a:t>their group count using local data.</a:t>
+              <a:t>cluster counts based on local environmental data.</a:t>
             </a:r>
           </a:p>
         </p:txBody>
@@ -8509,7 +8465,7 @@
               </a:defRPr>
             </a:pPr>
             <a:r>
-              <a:t>Figure 3. Mean R² from 30 later-year runs and five per held-out station, with</a:t>
+              <a:t>Figure 3. Mean R² across 30 later-year runs and five seeds per held-out</a:t>
             </a:r>
           </a:p>
           <a:p>
@@ -8531,7 +8487,7 @@
               </a:defRPr>
             </a:pPr>
             <a:r>
-              <a:t>matched seeds. Higher is better.</a:t>
+              <a:t>station, using matched seeds (higher is better).</a:t>
             </a:r>
           </a:p>
         </p:txBody>
@@ -8576,7 +8532,7 @@
               </a:defRPr>
             </a:pPr>
             <a:r>
-              <a:t>Two-regime R² is higher in all 30 later-year runs. Leaving out stations</a:t>
+              <a:t>The two-regime model achieves higher R² across all 30 later-year runs.</a:t>
             </a:r>
           </a:p>
           <a:p>
@@ -8598,7 +8554,7 @@
               </a:defRPr>
             </a:pPr>
             <a:r>
-              <a:t>also favors specialization on average, although improvements vary by</a:t>
+              <a:t>Spatial station holdouts also favor specialization on average (+0.0581</a:t>
             </a:r>
           </a:p>
           <a:p>
@@ -8620,7 +8576,7 @@
               </a:defRPr>
             </a:pPr>
             <a:r>
-              <a:t>location.</a:t>
+              <a:t>R²), though gains vary by regional coverage.</a:t>
             </a:r>
           </a:p>
         </p:txBody>
@@ -8689,7 +8645,7 @@
               </a:defRPr>
             </a:pPr>
             <a:r>
-              <a:t>Figure 4. Mean R² change: four gains and three losses (five runs).</a:t>
+              <a:t>Figure 4. Held-out station R² differences (four gains and three losses).</a:t>
             </a:r>
           </a:p>
         </p:txBody>
@@ -8703,7 +8659,7 @@
         <p:spPr>
           <a:xfrm>
             <a:off x="22174200" y="12714732"/>
-            <a:ext cx="10058400" cy="659383"/>
+            <a:ext cx="10058400" cy="989075"/>
           </a:xfrm>
           <a:prstGeom prst="rect">
             <a:avLst/>
@@ -8734,7 +8690,7 @@
               </a:defRPr>
             </a:pPr>
             <a:r>
-              <a:t>Cayuse Pass has the largest R² increase. Leaving out either eastern</a:t>
+              <a:t>Cayuse Pass gains +0.25 R². Conversely, withholding either eastern</a:t>
             </a:r>
           </a:p>
           <a:p>
@@ -8756,7 +8712,29 @@
               </a:defRPr>
             </a:pPr>
             <a:r>
-              <a:t>station reduces the smaller group's training coverage.</a:t>
+              <a:t>station removes half the drier group's data, underscoring sensitivity to</a:t>
+            </a:r>
+          </a:p>
+          <a:p>
+            <a:pPr algn="l">
+              <a:lnSpc>
+                <a:spcPts val="2595"/>
+              </a:lnSpc>
+              <a:spcBef>
+                <a:spcPts val="0"/>
+              </a:spcBef>
+              <a:spcAft>
+                <a:spcPts val="0"/>
+              </a:spcAft>
+              <a:defRPr sz="2200" b="0">
+                <a:solidFill>
+                  <a:srgbClr val="202B35"/>
+                </a:solidFill>
+                <a:latin typeface="DejaVu Sans"/>
+              </a:defRPr>
+            </a:pPr>
+            <a:r>
+              <a:t>sparse regional coverage.</a:t>
             </a:r>
           </a:p>
         </p:txBody>
@@ -8769,7 +8747,7 @@
         </p:nvSpPr>
         <p:spPr>
           <a:xfrm>
-            <a:off x="21991320" y="13483844"/>
+            <a:off x="21991320" y="13813535"/>
             <a:ext cx="10424160" cy="502920"/>
           </a:xfrm>
           <a:prstGeom prst="roundRect">
@@ -8816,7 +8794,7 @@
         </p:nvSpPr>
         <p:spPr>
           <a:xfrm>
-            <a:off x="22082760" y="13504875"/>
+            <a:off x="22082760" y="13834567"/>
             <a:ext cx="10241280" cy="466344"/>
           </a:xfrm>
           <a:prstGeom prst="rect">
@@ -8861,7 +8839,7 @@
         </p:nvSpPr>
         <p:spPr>
           <a:xfrm>
-            <a:off x="22174200" y="14142212"/>
+            <a:off x="22174200" y="14471904"/>
             <a:ext cx="10058400" cy="1318767"/>
           </a:xfrm>
           <a:prstGeom prst="rect">
@@ -8893,7 +8871,7 @@
               </a:defRPr>
             </a:pPr>
             <a:r>
-              <a:t>Missing SMAP inputs at five new sites deployed by Seattle University's</a:t>
+              <a:t>At five sensor sites deployed by Seattle University's ECE team, missing</a:t>
             </a:r>
           </a:p>
           <a:p>
@@ -8915,7 +8893,7 @@
               </a:defRPr>
             </a:pPr>
             <a:r>
-              <a:t>ECE team triggered automatic assignment using an index of recent</a:t>
+              <a:t>real-time SMAP retrievals triggered an automated fallback router using</a:t>
             </a:r>
           </a:p>
           <a:p>
@@ -8937,7 +8915,7 @@
               </a:defRPr>
             </a:pPr>
             <a:r>
-              <a:t>rainfall. We used Washington validation data to choose a specialist for</a:t>
+              <a:t>recent rainfall history. Regime thresholds were calibrated on</a:t>
             </a:r>
           </a:p>
           <a:p>
@@ -8959,7 +8937,7 @@
               </a:defRPr>
             </a:pPr>
             <a:r>
-              <a:t>each rainfall class.</a:t>
+              <a:t>Washington validation data without target labels.</a:t>
             </a:r>
           </a:p>
         </p:txBody>
@@ -8980,7 +8958,7 @@
         </p:blipFill>
         <p:spPr>
           <a:xfrm>
-            <a:off x="22219920" y="15570708"/>
+            <a:off x="22219920" y="15900400"/>
             <a:ext cx="9966960" cy="1920240"/>
           </a:xfrm>
           <a:prstGeom prst="rect">
@@ -8996,7 +8974,7 @@
         </p:nvSpPr>
         <p:spPr>
           <a:xfrm>
-            <a:off x="22174200" y="17554955"/>
+            <a:off x="22174200" y="17884648"/>
             <a:ext cx="10058400" cy="599439"/>
           </a:xfrm>
           <a:prstGeom prst="rect">
@@ -9028,7 +9006,7 @@
               </a:defRPr>
             </a:pPr>
             <a:r>
-              <a:t>Figure 5. Pooled ECE RMSE. Rainfall fallback and global model errors are</a:t>
+              <a:t>Figure 5. Pooled RMSE at ECE sites. The rainfall fallback matches global model</a:t>
             </a:r>
           </a:p>
           <a:p>
@@ -9050,7 +9028,7 @@
               </a:defRPr>
             </a:pPr>
             <a:r>
-              <a:t>similar; lower is better.</a:t>
+              <a:t>error (lower is better).</a:t>
             </a:r>
           </a:p>
         </p:txBody>
@@ -9063,7 +9041,7 @@
         </p:nvSpPr>
         <p:spPr>
           <a:xfrm>
-            <a:off x="22174200" y="18282411"/>
+            <a:off x="22174200" y="18612104"/>
             <a:ext cx="10058400" cy="989075"/>
           </a:xfrm>
           <a:prstGeom prst="rect">
@@ -9095,7 +9073,7 @@
               </a:defRPr>
             </a:pPr>
             <a:r>
-              <a:t>For all 150 daily observations from July 20 to August 19, 2026, the</a:t>
+              <a:t>During the dry summer period (July 20 to August 19, 2026; 150 daily</a:t>
             </a:r>
           </a:p>
           <a:p>
@@ -9117,7 +9095,7 @@
               </a:defRPr>
             </a:pPr>
             <a:r>
-              <a:t>fallback selected the same specialist. Full-season performance at these</a:t>
+              <a:t>observations), the fallback assigned all dates to the drier specialist.</a:t>
             </a:r>
           </a:p>
           <a:p>
@@ -9139,7 +9117,7 @@
               </a:defRPr>
             </a:pPr>
             <a:r>
-              <a:t>ECE sites remains untested.</a:t>
+              <a:t>Full-season multi-regime performance remains untested.</a:t>
             </a:r>
           </a:p>
         </p:txBody>
@@ -9152,7 +9130,7 @@
         </p:nvSpPr>
         <p:spPr>
           <a:xfrm>
-            <a:off x="21991320" y="19381216"/>
+            <a:off x="21991320" y="19710908"/>
             <a:ext cx="10424160" cy="502920"/>
           </a:xfrm>
           <a:prstGeom prst="roundRect">
@@ -9199,7 +9177,7 @@
         </p:nvSpPr>
         <p:spPr>
           <a:xfrm>
-            <a:off x="22082760" y="19402247"/>
+            <a:off x="22082760" y="19731939"/>
             <a:ext cx="10241280" cy="466344"/>
           </a:xfrm>
           <a:prstGeom prst="rect">
@@ -9244,8 +9222,8 @@
         </p:nvSpPr>
         <p:spPr>
           <a:xfrm>
-            <a:off x="22174200" y="20039583"/>
-            <a:ext cx="10058400" cy="1318767"/>
+            <a:off x="22174200" y="20369276"/>
+            <a:ext cx="10058400" cy="989075"/>
           </a:xfrm>
           <a:prstGeom prst="rect">
             <a:avLst/>
@@ -9276,7 +9254,7 @@
               </a:defRPr>
             </a:pPr>
             <a:r>
-              <a:t>These gains depend on reliable assignment and training sites that</a:t>
+              <a:t>Specialist gains rely on accurate routing and representative training</a:t>
             </a:r>
           </a:p>
           <a:p>
@@ -9298,7 +9276,7 @@
               </a:defRPr>
             </a:pPr>
             <a:r>
-              <a:t>cover the conditions encountered. We will test more Washington sites</a:t>
+              <a:t>networks. Future work evaluates multi-season ECE sensor data and</a:t>
             </a:r>
           </a:p>
           <a:p>
@@ -9320,29 +9298,7 @@
               </a:defRPr>
             </a:pPr>
             <a:r>
-              <a:t>and seasons with ECE sensors, including changes in satellite</a:t>
-            </a:r>
-          </a:p>
-          <a:p>
-            <a:pPr algn="l">
-              <a:lnSpc>
-                <a:spcPts val="2595"/>
-              </a:lnSpc>
-              <a:spcBef>
-                <a:spcPts val="0"/>
-              </a:spcBef>
-              <a:spcAft>
-                <a:spcPts val="0"/>
-              </a:spcAft>
-              <a:defRPr sz="2200" b="0">
-                <a:solidFill>
-                  <a:srgbClr val="202B35"/>
-                </a:solidFill>
-                <a:latin typeface="DejaVu Sans"/>
-              </a:defRPr>
-            </a:pPr>
-            <a:r>
-              <a:t>availability.</a:t>
+              <a:t>strengthens router robustness under intermittent satellite availability.</a:t>
             </a:r>
           </a:p>
         </p:txBody>

</xml_diff>